<commit_message>
Slides: shorten sd-09-009/010 copy to the ten-word budget, re-export PPTX
Co-Authored-By: Claude Opus 5.5 <noreply@anthropic.com>
Claude-Session: https://claude.ai/code/session_014EdyZwPF7XnU2uvEPKZ7Pf
</commit_message>
<xml_diff>
--- a/system-design-101/vi/lessons/sd-09-009/slides/sd-09-009.pptx
+++ b/system-design-101/vi/lessons/sd-09-009/slides/sd-09-009.pptx
@@ -1954,7 +1954,7 @@
               <a:buNone/>
             </a:pPr>
             <a:r>
-              <a:rPr lang="en-US" sz="3000" dirty="0" spc="-4" kern="0">
+              <a:rPr lang="en-US" sz="3000" dirty="0" spc="-1" kern="0">
                 <a:solidFill>
                   <a:srgbClr val="E4E1D8"/>
                 </a:solidFill>
@@ -1962,7 +1962,7 @@
                 <a:ea typeface="Be Vietnam Pro" pitchFamily="34" charset="-122"/>
                 <a:cs typeface="Be Vietnam Pro" pitchFamily="34" charset="-120"/>
               </a:rPr>
-              <a:t>Bạn</a:t>
+              <a:t>Muốn</a:t>
             </a:r>
             <a:r>
               <a:rPr lang="en-US" sz="3000" dirty="0" spc="1" kern="0">
@@ -1973,10 +1973,10 @@
                 <a:ea typeface="Be Vietnam Pro" pitchFamily="34" charset="-122"/>
                 <a:cs typeface="Be Vietnam Pro" pitchFamily="34" charset="-120"/>
               </a:rPr>
-              <a:t> muốn</a:t>
-            </a:r>
-            <a:r>
-              <a:rPr lang="en-US" sz="3000" dirty="0" spc="2" kern="0">
+              <a:t> diễn</a:t>
+            </a:r>
+            <a:r>
+              <a:rPr lang="en-US" sz="3000" dirty="0" spc="-1" kern="0">
                 <a:solidFill>
                   <a:srgbClr val="E4E1D8"/>
                 </a:solidFill>
@@ -1984,29 +1984,7 @@
                 <a:ea typeface="Be Vietnam Pro" pitchFamily="34" charset="-122"/>
                 <a:cs typeface="Be Vietnam Pro" pitchFamily="34" charset="-120"/>
               </a:rPr>
-              <a:t> diễn</a:t>
-            </a:r>
-            <a:r>
-              <a:rPr lang="en-US" sz="3000" dirty="0" spc="-2" kern="0">
-                <a:solidFill>
-                  <a:srgbClr val="E4E1D8"/>
-                </a:solidFill>
-                <a:latin typeface="Be Vietnam Pro" pitchFamily="34" charset="0"/>
-                <a:ea typeface="Be Vietnam Pro" pitchFamily="34" charset="-122"/>
-                <a:cs typeface="Be Vietnam Pro" pitchFamily="34" charset="-120"/>
-              </a:rPr>
               <a:t> đạt</a:t>
-            </a:r>
-            <a:r>
-              <a:rPr lang="en-US" sz="3000" dirty="0" spc="25" kern="0">
-                <a:solidFill>
-                  <a:srgbClr val="E4E1D8"/>
-                </a:solidFill>
-                <a:latin typeface="Be Vietnam Pro" pitchFamily="34" charset="0"/>
-                <a:ea typeface="Be Vietnam Pro" pitchFamily="34" charset="-122"/>
-                <a:cs typeface="Be Vietnam Pro" pitchFamily="34" charset="-120"/>
-              </a:rPr>
-              <a:t> điều</a:t>
             </a:r>
             <a:r>
               <a:rPr lang="en-US" sz="3000" dirty="0" spc="2" kern="0">
@@ -3019,28 +2997,6 @@
               </a:rPr>
               <a:t> hóa</a:t>
             </a:r>
-            <a:r>
-              <a:rPr lang="en-US" sz="2400" dirty="0" spc="2" kern="0">
-                <a:solidFill>
-                  <a:srgbClr val="E4E1D8"/>
-                </a:solidFill>
-                <a:latin typeface="Be Vietnam Pro" pitchFamily="34" charset="0"/>
-                <a:ea typeface="Be Vietnam Pro" pitchFamily="34" charset="-122"/>
-                <a:cs typeface="Be Vietnam Pro" pitchFamily="34" charset="-120"/>
-              </a:rPr>
-              <a:t> thống</a:t>
-            </a:r>
-            <a:r>
-              <a:rPr lang="en-US" sz="2400" dirty="0" spc="-8" kern="0">
-                <a:solidFill>
-                  <a:srgbClr val="E4E1D8"/>
-                </a:solidFill>
-                <a:latin typeface="Be Vietnam Pro" pitchFamily="34" charset="0"/>
-                <a:ea typeface="Be Vietnam Pro" pitchFamily="34" charset="-122"/>
-                <a:cs typeface="Be Vietnam Pro" pitchFamily="34" charset="-120"/>
-              </a:rPr>
-              <a:t> nhất</a:t>
-            </a:r>
             <a:endParaRPr lang="en-US" sz="2400" dirty="0"/>
           </a:p>
         </p:txBody>
@@ -3178,7 +3134,7 @@
               <a:t> mã</a:t>
             </a:r>
             <a:r>
-              <a:rPr lang="en-US" sz="2400" dirty="0" spc="0" kern="0">
+              <a:rPr lang="en-US" sz="2400" dirty="0" spc="-2" kern="0">
                 <a:solidFill>
                   <a:srgbClr val="E4E1D8"/>
                 </a:solidFill>
@@ -3186,10 +3142,10 @@
                 <a:ea typeface="Be Vietnam Pro" pitchFamily="34" charset="-122"/>
                 <a:cs typeface="Be Vietnam Pro" pitchFamily="34" charset="-120"/>
               </a:rPr>
-              <a:t> chuẩn</a:t>
-            </a:r>
-            <a:r>
-              <a:rPr lang="en-US" sz="2400" dirty="0" spc="-1" kern="0">
+              <a:t> ký</a:t>
+            </a:r>
+            <a:r>
+              <a:rPr lang="en-US" sz="2400" dirty="0" spc="4" kern="0">
                 <a:solidFill>
                   <a:srgbClr val="E4E1D8"/>
                 </a:solidFill>
@@ -3197,40 +3153,7 @@
                 <a:ea typeface="Be Vietnam Pro" pitchFamily="34" charset="-122"/>
                 <a:cs typeface="Be Vietnam Pro" pitchFamily="34" charset="-120"/>
               </a:rPr>
-              <a:t> cho ký</a:t>
-            </a:r>
-            <a:r>
-              <a:rPr lang="en-US" sz="2400" dirty="0" spc="4" kern="0">
-                <a:solidFill>
-                  <a:srgbClr val="E4E1D8"/>
-                </a:solidFill>
-                <a:latin typeface="Be Vietnam Pro" pitchFamily="34" charset="0"/>
-                <a:ea typeface="Be Vietnam Pro" pitchFamily="34" charset="-122"/>
-                <a:cs typeface="Be Vietnam Pro" pitchFamily="34" charset="-120"/>
-              </a:rPr>
               <a:t> tự</a:t>
-            </a:r>
-            <a:r>
-              <a:rPr lang="en-US" sz="2400" dirty="0" spc="0" kern="0">
-                <a:solidFill>
-                  <a:srgbClr val="E4E1D8"/>
-                </a:solidFill>
-                <a:latin typeface="Be Vietnam Pro" pitchFamily="34" charset="0"/>
-                <a:ea typeface="Be Vietnam Pro" pitchFamily="34" charset="-122"/>
-                <a:cs typeface="Be Vietnam Pro" pitchFamily="34" charset="-120"/>
-              </a:rPr>
-              <a:t> cơ</a:t>
-            </a:r>
-            <a:r>
-              <a:rPr lang="en-US" sz="2400" dirty="0" spc="-1" kern="0">
-                <a:solidFill>
-                  <a:srgbClr val="E4E1D8"/>
-                </a:solidFill>
-                <a:latin typeface="Be Vietnam Pro" pitchFamily="34" charset="0"/>
-                <a:ea typeface="Be Vietnam Pro" pitchFamily="34" charset="-122"/>
-                <a:cs typeface="Be Vietnam Pro" pitchFamily="34" charset="-120"/>
-              </a:rPr>
-              <a:t> bản</a:t>
             </a:r>
             <a:endParaRPr lang="en-US" sz="2400" dirty="0"/>
           </a:p>
@@ -4696,29 +4619,7 @@
               <a:t> nơi</a:t>
             </a:r>
             <a:r>
-              <a:rPr lang="en-US" sz="2250" b="1" dirty="0" spc="9" kern="0">
-                <a:solidFill>
-                  <a:srgbClr val="14161C"/>
-                </a:solidFill>
-                <a:latin typeface="Be Vietnam Pro" pitchFamily="34" charset="0"/>
-                <a:ea typeface="Be Vietnam Pro" pitchFamily="34" charset="-122"/>
-                <a:cs typeface="Be Vietnam Pro" pitchFamily="34" charset="-120"/>
-              </a:rPr>
-              <a:t> người</a:t>
-            </a:r>
-            <a:r>
-              <a:rPr lang="en-US" sz="2250" b="1" dirty="0" spc="6" kern="0">
-                <a:solidFill>
-                  <a:srgbClr val="14161C"/>
-                </a:solidFill>
-                <a:latin typeface="Be Vietnam Pro" pitchFamily="34" charset="0"/>
-                <a:ea typeface="Be Vietnam Pro" pitchFamily="34" charset="-122"/>
-                <a:cs typeface="Be Vietnam Pro" pitchFamily="34" charset="-120"/>
-              </a:rPr>
-              <a:t> đọc</a:t>
-            </a:r>
-            <a:r>
-              <a:rPr lang="en-US" sz="2250" b="1" dirty="0" spc="-20" kern="0">
+              <a:rPr lang="en-US" sz="2250" b="1" dirty="0" spc="-19" kern="0">
                 <a:solidFill>
                   <a:srgbClr val="14161C"/>
                 </a:solidFill>
@@ -8781,40 +8682,18 @@
               <a:buNone/>
             </a:pPr>
             <a:r>
-              <a:rPr lang="en-US" sz="2850" dirty="0" spc="-16" kern="0">
-                <a:solidFill>
-                  <a:srgbClr val="14161C"/>
-                </a:solidFill>
-                <a:latin typeface="Be Vietnam Pro" pitchFamily="34" charset="0"/>
-                <a:ea typeface="Be Vietnam Pro" pitchFamily="34" charset="-122"/>
-                <a:cs typeface="Be Vietnam Pro" pitchFamily="34" charset="-120"/>
-              </a:rPr>
-              <a:t>Đây</a:t>
-            </a:r>
-            <a:r>
-              <a:rPr lang="en-US" sz="2850" dirty="0" spc="1" kern="0">
-                <a:solidFill>
-                  <a:srgbClr val="14161C"/>
-                </a:solidFill>
-                <a:latin typeface="Be Vietnam Pro" pitchFamily="34" charset="0"/>
-                <a:ea typeface="Be Vietnam Pro" pitchFamily="34" charset="-122"/>
-                <a:cs typeface="Be Vietnam Pro" pitchFamily="34" charset="-120"/>
-              </a:rPr>
-              <a:t> là</a:t>
-            </a:r>
-            <a:r>
-              <a:rPr lang="en-US" sz="2850" dirty="0" spc="-9" kern="0">
-                <a:solidFill>
-                  <a:srgbClr val="14161C"/>
-                </a:solidFill>
-                <a:latin typeface="Be Vietnam Pro" pitchFamily="34" charset="0"/>
-                <a:ea typeface="Be Vietnam Pro" pitchFamily="34" charset="-122"/>
-                <a:cs typeface="Be Vietnam Pro" pitchFamily="34" charset="-120"/>
-              </a:rPr>
-              <a:t> một</a:t>
-            </a:r>
-            <a:r>
-              <a:rPr lang="en-US" sz="2850" dirty="0" spc="-1" kern="0">
+              <a:rPr lang="en-US" sz="2850" dirty="0" spc="-11" kern="0">
+                <a:solidFill>
+                  <a:srgbClr val="14161C"/>
+                </a:solidFill>
+                <a:latin typeface="Be Vietnam Pro" pitchFamily="34" charset="0"/>
+                <a:ea typeface="Be Vietnam Pro" pitchFamily="34" charset="-122"/>
+                <a:cs typeface="Be Vietnam Pro" pitchFamily="34" charset="-120"/>
+              </a:rPr>
+              <a:t>Một</a:t>
+            </a:r>
+            <a:r>
+              <a:rPr lang="en-US" sz="2850" dirty="0" spc="0" kern="0">
                 <a:solidFill>
                   <a:srgbClr val="14161C"/>
                 </a:solidFill>
@@ -8825,7 +8704,7 @@
               <a:t> cách</a:t>
             </a:r>
             <a:r>
-              <a:rPr lang="en-US" sz="2850" dirty="0" spc="-11" kern="0">
+              <a:rPr lang="en-US" sz="2850" dirty="0" spc="-12" kern="0">
                 <a:solidFill>
                   <a:srgbClr val="14161C"/>
                 </a:solidFill>
@@ -11289,7 +11168,29 @@
                 <a:ea typeface="Be Vietnam Pro" pitchFamily="34" charset="-122"/>
                 <a:cs typeface="Be Vietnam Pro" pitchFamily="34" charset="-120"/>
               </a:rPr>
-              <a:t> Markmap,</a:t>
+              <a:t> Markmap, biến</a:t>
+            </a:r>
+            <a:r>
+              <a:rPr lang="en-US" sz="2550" dirty="0" spc="-18" kern="0">
+                <a:solidFill>
+                  <a:srgbClr val="14161C"/>
+                </a:solidFill>
+                <a:latin typeface="Be Vietnam Pro" pitchFamily="34" charset="0"/>
+                <a:ea typeface="Be Vietnam Pro" pitchFamily="34" charset="-122"/>
+                <a:cs typeface="Be Vietnam Pro" pitchFamily="34" charset="-120"/>
+              </a:rPr>
+              <a:t> Markdown</a:t>
+            </a:r>
+            <a:r>
+              <a:rPr lang="en-US" sz="2550" dirty="0" spc="1" kern="0">
+                <a:solidFill>
+                  <a:srgbClr val="14161C"/>
+                </a:solidFill>
+                <a:latin typeface="Be Vietnam Pro" pitchFamily="34" charset="0"/>
+                <a:ea typeface="Be Vietnam Pro" pitchFamily="34" charset="-122"/>
+                <a:cs typeface="Be Vietnam Pro" pitchFamily="34" charset="-120"/>
+              </a:rPr>
+              <a:t> thành</a:t>
             </a:r>
             <a:r>
               <a:rPr lang="en-US" sz="2550" dirty="0" spc="-1" kern="0">
@@ -11300,62 +11201,7 @@
                 <a:ea typeface="Be Vietnam Pro" pitchFamily="34" charset="-122"/>
                 <a:cs typeface="Be Vietnam Pro" pitchFamily="34" charset="-120"/>
               </a:rPr>
-              <a:t> vì nó</a:t>
-            </a:r>
-            <a:r>
-              <a:rPr lang="en-US" sz="2550" dirty="0" spc="0" kern="0">
-                <a:solidFill>
-                  <a:srgbClr val="14161C"/>
-                </a:solidFill>
-                <a:latin typeface="Be Vietnam Pro" pitchFamily="34" charset="0"/>
-                <a:ea typeface="Be Vietnam Pro" pitchFamily="34" charset="-122"/>
-                <a:cs typeface="Be Vietnam Pro" pitchFamily="34" charset="-120"/>
-              </a:rPr>
-              <a:t> biến</a:t>
-            </a:r>
-            <a:r>
-              <a:rPr lang="en-US" sz="2550" dirty="0" spc="2" kern="0">
-                <a:solidFill>
-                  <a:srgbClr val="14161C"/>
-                </a:solidFill>
-                <a:latin typeface="Be Vietnam Pro" pitchFamily="34" charset="0"/>
-                <a:ea typeface="Be Vietnam Pro" pitchFamily="34" charset="-122"/>
-                <a:cs typeface="Be Vietnam Pro" pitchFamily="34" charset="-120"/>
-              </a:rPr>
-              <a:t> cấu</a:t>
-            </a:r>
-            <a:r>
-              <a:rPr lang="en-US" sz="2550" dirty="0" spc="0" kern="0">
-                <a:solidFill>
-                  <a:srgbClr val="14161C"/>
-                </a:solidFill>
-                <a:latin typeface="Be Vietnam Pro" pitchFamily="34" charset="0"/>
-                <a:ea typeface="Be Vietnam Pro" pitchFamily="34" charset="-122"/>
-                <a:cs typeface="Be Vietnam Pro" pitchFamily="34" charset="-120"/>
-              </a:rPr>
-              <a:t> trúc</a:t>
-            </a:r>
-            <a:r>
-              <a:rPr lang="en-US" sz="2550" dirty="0" spc="-18" kern="0">
-                <a:solidFill>
-                  <a:srgbClr val="14161C"/>
-                </a:solidFill>
-                <a:latin typeface="Be Vietnam Pro" pitchFamily="34" charset="0"/>
-                <a:ea typeface="Be Vietnam Pro" pitchFamily="34" charset="-122"/>
-                <a:cs typeface="Be Vietnam Pro" pitchFamily="34" charset="-120"/>
-              </a:rPr>
-              <a:t> Markdown</a:t>
-            </a:r>
-            <a:r>
-              <a:rPr lang="en-US" sz="2550" dirty="0" spc="0" kern="0">
-                <a:solidFill>
-                  <a:srgbClr val="14161C"/>
-                </a:solidFill>
-                <a:latin typeface="Be Vietnam Pro" pitchFamily="34" charset="0"/>
-                <a:ea typeface="Be Vietnam Pro" pitchFamily="34" charset="-122"/>
-                <a:cs typeface="Be Vietnam Pro" pitchFamily="34" charset="-120"/>
-              </a:rPr>
-              <a:t> thành mind</a:t>
+              <a:t> mind</a:t>
             </a:r>
             <a:r>
               <a:rPr lang="en-US" sz="2550" dirty="0" spc="1" kern="0">

</xml_diff>